<commit_message>
Update deck closing slide
</commit_message>
<xml_diff>
--- a/IMF_WEO_Capstone_Deck.pptx
+++ b/IMF_WEO_Capstone_Deck.pptx
@@ -121,25 +121,25 @@
   <p:extLst>
     <p:ext uri="{521415D9-36F7-43E2-AB2F-B90AF26B5E84}">
       <p14:sectionLst xmlns:p14="http://schemas.microsoft.com/office/powerpoint/2010/main">
-        <p14:section name="Opening" id="{37108c4a-320e-5e3b-8c50-ac1276b8d681}">
+        <p14:section name="Opening" id="{79487551-cf54-6ab5-8c23-4b46852e6899}">
           <p14:sldIdLst>
             <p14:sldId id="256"/>
           </p14:sldIdLst>
         </p14:section>
-        <p14:section name="1. Context &amp; Data" id="{2b59e7bd-0dc8-7c0a-1d68-c011c940d47e}">
+        <p14:section name="1. Context &amp; Data" id="{af8d04e2-aadd-87d2-a48a-35e4f1ab2cc5}">
           <p14:sldIdLst>
             <p14:sldId id="257"/>
             <p14:sldId id="258"/>
             <p14:sldId id="259"/>
           </p14:sldIdLst>
         </p14:section>
-        <p14:section name="2. Data Description" id="{2f1e4db4-a7cf-d83b-8f39-44367cb505e1}">
+        <p14:section name="2. Data Description" id="{0bcbee29-a7c0-bca9-f6de-649eea017f50}">
           <p14:sldIdLst>
             <p14:sldId id="260"/>
             <p14:sldId id="261"/>
           </p14:sldIdLst>
         </p14:section>
-        <p14:section name="3. Regression &amp; Feature Selection" id="{89df7a58-d1fd-84b4-c575-c8f5996063c2}">
+        <p14:section name="3. Regression &amp; Feature Selection" id="{eef4f45a-d201-be73-e126-b2a5631c379b}">
           <p14:sldIdLst>
             <p14:sldId id="262"/>
             <p14:sldId id="263"/>
@@ -148,13 +148,13 @@
             <p14:sldId id="266"/>
           </p14:sldIdLst>
         </p14:section>
-        <p14:section name="4. Time Series Analysis" id="{fbd3b2c0-e324-3078-de18-730268dd8cf2}">
+        <p14:section name="4. Time Series Analysis" id="{53b8e509-1217-b03d-9223-eaecd43e9e46}">
           <p14:sldIdLst>
             <p14:sldId id="267"/>
             <p14:sldId id="268"/>
           </p14:sldIdLst>
         </p14:section>
-        <p14:section name="5. Conclusions" id="{331a2aa9-b60f-2e58-4d3b-8e9f3c308c50}">
+        <p14:section name="5. Conclusions" id="{f8cc6a6e-e574-1a06-71e4-ae0080cd8c59}">
           <p14:sldIdLst>
             <p14:sldId id="269"/>
             <p14:sldId id="270"/>
@@ -1121,7 +1121,8 @@
             <a:r>
               <a:rPr lang="en-US" dirty="0"/>
               <a:t>Closing slide.
-The notebook is the single source of truth: every number, table and chart in this deck is produced by IMF_WEO_Capstone_Analysis.ipynb, executed end to end with all outputs retained. Nothing in the deck was typed in by hand, which is what makes the whole analysis reproducible.
+Close on the two sentences on screen rather than re-listing the findings - the audience has just seen them.
+The notebook is the single source of truth: every number, table and chart in this deck comes from IMF_WEO_Capstone_Analysis.ipynb, with the random seed fixed at 42 so the whole analysis reproduces exactly on re-run.
 The repository holds the notebook, the source CSV, the figures folder, this deck and a README stating the problem, the methods and the headline findings — so the whole analysis can be re-run end to end by anyone who opens it.
 GitHub renders the README as the repository's front page and previews the notebook in the browser with all outputs intact, so a reviewer can read the entire analysis without downloading or installing anything.</a:t>
             </a:r>
@@ -8117,7 +8118,7 @@
                   <a:schemeClr val="bg1"/>
                 </a:solidFill>
               </a:rPr>
-              <a:t>Reproducibility and repository</a:t>
+              <a:t>Thank you</a:t>
             </a:r>
             <a:endParaRPr lang="en-US" sz="3200" dirty="0"/>
           </a:p>
@@ -8131,7 +8132,7 @@
         </p:nvSpPr>
         <p:spPr>
           <a:xfrm>
-            <a:off x="822960" y="1371600"/>
+            <a:off x="822960" y="1389888"/>
             <a:ext cx="10515600" cy="365760"/>
           </a:xfrm>
           <a:prstGeom prst="rect">
@@ -8148,31 +8149,277 @@
               <a:buNone/>
             </a:pPr>
             <a:r>
-              <a:rPr lang="en-US" sz="1500" dirty="0">
+              <a:rPr lang="en-US" sz="1600" dirty="0">
                 <a:solidFill>
                   <a:srgbClr val="CADCFC"/>
                 </a:solidFill>
               </a:rPr>
-              <a:t>Everything in this deck is reproducible from a single notebook</a:t>
-            </a:r>
-            <a:endParaRPr lang="en-US" sz="1500" dirty="0"/>
-          </a:p>
-        </p:txBody>
-      </p:sp>
-      <p:sp>
-        <p:nvSpPr>
-          <p:cNvPr id="4" name="asset-0"/>
+              <a:t>Questions and discussion welcome</a:t>
+            </a:r>
+            <a:endParaRPr lang="en-US" sz="1600" dirty="0"/>
+          </a:p>
+        </p:txBody>
+      </p:sp>
+      <p:sp>
+        <p:nvSpPr>
+          <p:cNvPr id="4" name="Text 2"/>
+          <p:cNvSpPr txBox="1"/>
+          <p:nvPr/>
+        </p:nvSpPr>
+        <p:spPr>
+          <a:xfrm>
+            <a:off x="822960" y="2212848"/>
+            <a:ext cx="6492240" cy="274320"/>
+          </a:xfrm>
+          <a:prstGeom prst="rect">
+            <a:avLst/>
+          </a:prstGeom>
+          <a:noFill/>
+          <a:ln/>
+        </p:spPr>
+        <p:txBody>
+          <a:bodyPr wrap="square" lIns="0" tIns="0" rIns="0" bIns="0" rtlCol="0" anchor="ctr"/>
+          <a:lstStyle/>
+          <a:p>
+            <a:pPr indent="0" marL="0">
+              <a:buNone/>
+            </a:pPr>
+            <a:r>
+              <a:rPr lang="en-US" sz="1050" b="1" spc="150" kern="0" dirty="0">
+                <a:solidFill>
+                  <a:srgbClr val="D4A017"/>
+                </a:solidFill>
+              </a:rPr>
+              <a:t>WHAT THE ANALYSIS FOUND</a:t>
+            </a:r>
+            <a:endParaRPr lang="en-US" sz="1050" dirty="0"/>
+          </a:p>
+        </p:txBody>
+      </p:sp>
+      <p:sp>
+        <p:nvSpPr>
+          <p:cNvPr id="5" name="Text 3"/>
+          <p:cNvSpPr txBox="1"/>
+          <p:nvPr/>
+        </p:nvSpPr>
+        <p:spPr>
+          <a:xfrm>
+            <a:off x="822960" y="2560320"/>
+            <a:ext cx="6492240" cy="1920240"/>
+          </a:xfrm>
+          <a:prstGeom prst="rect">
+            <a:avLst/>
+          </a:prstGeom>
+          <a:noFill/>
+          <a:ln/>
+        </p:spPr>
+        <p:txBody>
+          <a:bodyPr wrap="square" lIns="0" tIns="0" rIns="0" bIns="0" rtlCol="0" anchor="ctr"/>
+          <a:lstStyle/>
+          <a:p>
+            <a:pPr indent="0" marL="0">
+              <a:lnSpc>
+                <a:spcPct val="118000"/>
+              </a:lnSpc>
+              <a:buNone/>
+            </a:pPr>
+            <a:r>
+              <a:rPr lang="en-US" sz="1400" dirty="0">
+                <a:solidFill>
+                  <a:srgbClr val="FFFFFF"/>
+                </a:solidFill>
+              </a:rPr>
+              <a:t>Growth, debt and inflation explain 87% of a country's economic resilience — and three model families with different assumptions agree on that ranking.</a:t>
+            </a:r>
+            <a:endParaRPr lang="en-US" sz="1400" dirty="0"/>
+          </a:p>
+          <a:p>
+            <a:pPr indent="0" marL="0">
+              <a:lnSpc>
+                <a:spcPct val="118000"/>
+              </a:lnSpc>
+              <a:buNone/>
+            </a:pPr>
+            <a:endParaRPr lang="en-US" sz="1400" dirty="0"/>
+          </a:p>
+          <a:p>
+            <a:pPr indent="0" marL="0">
+              <a:lnSpc>
+                <a:spcPct val="118000"/>
+              </a:lnSpc>
+              <a:buNone/>
+            </a:pPr>
+            <a:r>
+              <a:rPr lang="en-US" sz="1400" dirty="0">
+                <a:solidFill>
+                  <a:srgbClr val="FFFFFF"/>
+                </a:solidFill>
+              </a:rPr>
+              <a:t>For India, the IMF's path to 2030 implies a 3.3 pp acceleration on the past decade, which a trend-following model cannot see.</a:t>
+            </a:r>
+            <a:endParaRPr lang="en-US" sz="1400" dirty="0"/>
+          </a:p>
+        </p:txBody>
+      </p:sp>
+      <p:sp>
+        <p:nvSpPr>
+          <p:cNvPr id="6" name="repo-card"/>
           <p:cNvSpPr/>
           <p:nvPr/>
         </p:nvSpPr>
         <p:spPr>
           <a:xfrm>
-            <a:off x="822960" y="2011680"/>
-            <a:ext cx="6492240" cy="694944"/>
+            <a:off x="7635240" y="2212848"/>
+            <a:ext cx="3703320" cy="1920240"/>
           </a:xfrm>
           <a:prstGeom prst="roundRect">
             <a:avLst>
-              <a:gd name="adj" fmla="val 7895"/>
+              <a:gd name="adj" fmla="val 3333"/>
+            </a:avLst>
+          </a:prstGeom>
+          <a:solidFill>
+            <a:srgbClr val="1E2E4A"/>
+          </a:solidFill>
+          <a:ln w="15875">
+            <a:solidFill>
+              <a:srgbClr val="D4A017"/>
+            </a:solidFill>
+            <a:prstDash val="solid"/>
+          </a:ln>
+        </p:spPr>
+      </p:sp>
+      <p:sp>
+        <p:nvSpPr>
+          <p:cNvPr id="7" name="Text 5"/>
+          <p:cNvSpPr txBox="1"/>
+          <p:nvPr/>
+        </p:nvSpPr>
+        <p:spPr>
+          <a:xfrm>
+            <a:off x="7863840" y="2377440"/>
+            <a:ext cx="3246120" cy="274320"/>
+          </a:xfrm>
+          <a:prstGeom prst="rect">
+            <a:avLst/>
+          </a:prstGeom>
+          <a:noFill/>
+          <a:ln/>
+        </p:spPr>
+        <p:txBody>
+          <a:bodyPr wrap="square" lIns="0" tIns="0" rIns="0" bIns="0" rtlCol="0" anchor="ctr"/>
+          <a:lstStyle/>
+          <a:p>
+            <a:pPr indent="0" marL="0">
+              <a:buNone/>
+            </a:pPr>
+            <a:r>
+              <a:rPr lang="en-US" sz="1050" b="1" spc="150" kern="0" dirty="0">
+                <a:solidFill>
+                  <a:srgbClr val="D4A017"/>
+                </a:solidFill>
+              </a:rPr>
+              <a:t>CODE AND DATA</a:t>
+            </a:r>
+            <a:endParaRPr lang="en-US" sz="1050" dirty="0"/>
+          </a:p>
+        </p:txBody>
+      </p:sp>
+      <p:sp>
+        <p:nvSpPr>
+          <p:cNvPr id="8" name="Text 6"/>
+          <p:cNvSpPr txBox="1"/>
+          <p:nvPr/>
+        </p:nvSpPr>
+        <p:spPr>
+          <a:xfrm>
+            <a:off x="7863840" y="2724912"/>
+            <a:ext cx="3246120" cy="1280160"/>
+          </a:xfrm>
+          <a:prstGeom prst="rect">
+            <a:avLst/>
+          </a:prstGeom>
+          <a:noFill/>
+          <a:ln/>
+        </p:spPr>
+        <p:txBody>
+          <a:bodyPr wrap="square" lIns="0" tIns="0" rIns="0" bIns="0" rtlCol="0" anchor="ctr"/>
+          <a:lstStyle/>
+          <a:p>
+            <a:pPr indent="0" marL="0">
+              <a:lnSpc>
+                <a:spcPct val="110000"/>
+              </a:lnSpc>
+              <a:buNone/>
+            </a:pPr>
+            <a:r>
+              <a:rPr lang="en-US" sz="1250" dirty="0">
+                <a:solidFill>
+                  <a:srgbClr val="FFFFFF"/>
+                </a:solidFill>
+              </a:rPr>
+              <a:t>github.com/swayd03/</a:t>
+            </a:r>
+            <a:endParaRPr lang="en-US" sz="1100" dirty="0"/>
+          </a:p>
+          <a:p>
+            <a:pPr indent="0" marL="0">
+              <a:lnSpc>
+                <a:spcPct val="110000"/>
+              </a:lnSpc>
+              <a:buNone/>
+            </a:pPr>
+            <a:r>
+              <a:rPr lang="en-US" sz="1250" dirty="0">
+                <a:solidFill>
+                  <a:srgbClr val="FFFFFF"/>
+                </a:solidFill>
+              </a:rPr>
+              <a:t>imf-weo-capstone</a:t>
+            </a:r>
+            <a:endParaRPr lang="en-US" sz="1100" dirty="0"/>
+          </a:p>
+          <a:p>
+            <a:pPr indent="0" marL="0">
+              <a:lnSpc>
+                <a:spcPct val="110000"/>
+              </a:lnSpc>
+              <a:buNone/>
+            </a:pPr>
+            <a:endParaRPr lang="en-US" sz="1100" dirty="0"/>
+          </a:p>
+          <a:p>
+            <a:pPr indent="0" marL="0">
+              <a:lnSpc>
+                <a:spcPct val="110000"/>
+              </a:lnSpc>
+              <a:buNone/>
+            </a:pPr>
+            <a:r>
+              <a:rPr lang="en-US" sz="1050" dirty="0">
+                <a:solidFill>
+                  <a:srgbClr val="8FA6C4"/>
+                </a:solidFill>
+              </a:rPr>
+              <a:t>Notebook, dataset and figures</a:t>
+            </a:r>
+            <a:endParaRPr lang="en-US" sz="1100" dirty="0"/>
+          </a:p>
+        </p:txBody>
+      </p:sp>
+      <p:sp>
+        <p:nvSpPr>
+          <p:cNvPr id="9" name="submission-card"/>
+          <p:cNvSpPr/>
+          <p:nvPr/>
+        </p:nvSpPr>
+        <p:spPr>
+          <a:xfrm>
+            <a:off x="822960" y="4809744"/>
+            <a:ext cx="10515600" cy="658368"/>
+          </a:xfrm>
+          <a:prstGeom prst="roundRect">
+            <a:avLst>
+              <a:gd name="adj" fmla="val 8333"/>
             </a:avLst>
           </a:prstGeom>
           <a:solidFill>
@@ -8188,14 +8435,14 @@
       </p:sp>
       <p:sp>
         <p:nvSpPr>
-          <p:cNvPr id="5" name="Text 3"/>
+          <p:cNvPr id="10" name="Text 8"/>
           <p:cNvSpPr txBox="1"/>
           <p:nvPr/>
         </p:nvSpPr>
         <p:spPr>
           <a:xfrm>
-            <a:off x="1042416" y="2066544"/>
-            <a:ext cx="6035040" cy="310896"/>
+            <a:off x="1042416" y="4809744"/>
+            <a:ext cx="10058400" cy="658368"/>
           </a:xfrm>
           <a:prstGeom prst="rect">
             <a:avLst/>
@@ -8211,482 +8458,6 @@
               <a:buNone/>
             </a:pPr>
             <a:r>
-              <a:rPr lang="en-US" sz="1300" b="1" dirty="0">
-                <a:solidFill>
-                  <a:srgbClr val="FFFFFF"/>
-                </a:solidFill>
-              </a:rPr>
-              <a:t>IMF_WEO_Capstone_Analysis.ipynb</a:t>
-            </a:r>
-            <a:endParaRPr lang="en-US" sz="1300" dirty="0"/>
-          </a:p>
-        </p:txBody>
-      </p:sp>
-      <p:sp>
-        <p:nvSpPr>
-          <p:cNvPr id="6" name="Text 4"/>
-          <p:cNvSpPr txBox="1"/>
-          <p:nvPr/>
-        </p:nvSpPr>
-        <p:spPr>
-          <a:xfrm>
-            <a:off x="1042416" y="2377440"/>
-            <a:ext cx="6035040" cy="274320"/>
-          </a:xfrm>
-          <a:prstGeom prst="rect">
-            <a:avLst/>
-          </a:prstGeom>
-          <a:noFill/>
-          <a:ln/>
-        </p:spPr>
-        <p:txBody>
-          <a:bodyPr wrap="square" lIns="0" tIns="0" rIns="0" bIns="0" rtlCol="0" anchor="ctr"/>
-          <a:lstStyle/>
-          <a:p>
-            <a:pPr indent="0" marL="0">
-              <a:buNone/>
-            </a:pPr>
-            <a:r>
-              <a:rPr lang="en-US" sz="1050" dirty="0">
-                <a:solidFill>
-                  <a:srgbClr val="8FA6C4"/>
-                </a:solidFill>
-              </a:rPr>
-              <a:t>44 cells, fully executed, all outputs retained</a:t>
-            </a:r>
-            <a:endParaRPr lang="en-US" sz="1050" dirty="0"/>
-          </a:p>
-        </p:txBody>
-      </p:sp>
-      <p:sp>
-        <p:nvSpPr>
-          <p:cNvPr id="7" name="asset-1"/>
-          <p:cNvSpPr/>
-          <p:nvPr/>
-        </p:nvSpPr>
-        <p:spPr>
-          <a:xfrm>
-            <a:off x="822960" y="2852928"/>
-            <a:ext cx="6492240" cy="694944"/>
-          </a:xfrm>
-          <a:prstGeom prst="roundRect">
-            <a:avLst>
-              <a:gd name="adj" fmla="val 7895"/>
-            </a:avLst>
-          </a:prstGeom>
-          <a:solidFill>
-            <a:srgbClr val="1E2E4A"/>
-          </a:solidFill>
-          <a:ln w="12700">
-            <a:solidFill>
-              <a:srgbClr val="1E2E4A"/>
-            </a:solidFill>
-            <a:prstDash val="solid"/>
-          </a:ln>
-        </p:spPr>
-      </p:sp>
-      <p:sp>
-        <p:nvSpPr>
-          <p:cNvPr id="8" name="Text 6"/>
-          <p:cNvSpPr txBox="1"/>
-          <p:nvPr/>
-        </p:nvSpPr>
-        <p:spPr>
-          <a:xfrm>
-            <a:off x="1042416" y="2907792"/>
-            <a:ext cx="6035040" cy="310896"/>
-          </a:xfrm>
-          <a:prstGeom prst="rect">
-            <a:avLst/>
-          </a:prstGeom>
-          <a:noFill/>
-          <a:ln/>
-        </p:spPr>
-        <p:txBody>
-          <a:bodyPr wrap="square" lIns="0" tIns="0" rIns="0" bIns="0" rtlCol="0" anchor="ctr"/>
-          <a:lstStyle/>
-          <a:p>
-            <a:pPr indent="0" marL="0">
-              <a:buNone/>
-            </a:pPr>
-            <a:r>
-              <a:rPr lang="en-US" sz="1300" b="1" dirty="0">
-                <a:solidFill>
-                  <a:srgbClr val="FFFFFF"/>
-                </a:solidFill>
-              </a:rPr>
-              <a:t>figures/ — 11 charts</a:t>
-            </a:r>
-            <a:endParaRPr lang="en-US" sz="1300" dirty="0"/>
-          </a:p>
-        </p:txBody>
-      </p:sp>
-      <p:sp>
-        <p:nvSpPr>
-          <p:cNvPr id="9" name="Text 7"/>
-          <p:cNvSpPr txBox="1"/>
-          <p:nvPr/>
-        </p:nvSpPr>
-        <p:spPr>
-          <a:xfrm>
-            <a:off x="1042416" y="3218688"/>
-            <a:ext cx="6035040" cy="274320"/>
-          </a:xfrm>
-          <a:prstGeom prst="rect">
-            <a:avLst/>
-          </a:prstGeom>
-          <a:noFill/>
-          <a:ln/>
-        </p:spPr>
-        <p:txBody>
-          <a:bodyPr wrap="square" lIns="0" tIns="0" rIns="0" bIns="0" rtlCol="0" anchor="ctr"/>
-          <a:lstStyle/>
-          <a:p>
-            <a:pPr indent="0" marL="0">
-              <a:buNone/>
-            </a:pPr>
-            <a:r>
-              <a:rPr lang="en-US" sz="1050" dirty="0">
-                <a:solidFill>
-                  <a:srgbClr val="8FA6C4"/>
-                </a:solidFill>
-              </a:rPr>
-              <a:t>Every figure in this deck, generated by the notebook</a:t>
-            </a:r>
-            <a:endParaRPr lang="en-US" sz="1050" dirty="0"/>
-          </a:p>
-        </p:txBody>
-      </p:sp>
-      <p:sp>
-        <p:nvSpPr>
-          <p:cNvPr id="10" name="asset-2"/>
-          <p:cNvSpPr/>
-          <p:nvPr/>
-        </p:nvSpPr>
-        <p:spPr>
-          <a:xfrm>
-            <a:off x="822960" y="3694176"/>
-            <a:ext cx="6492240" cy="694944"/>
-          </a:xfrm>
-          <a:prstGeom prst="roundRect">
-            <a:avLst>
-              <a:gd name="adj" fmla="val 7895"/>
-            </a:avLst>
-          </a:prstGeom>
-          <a:solidFill>
-            <a:srgbClr val="1E2E4A"/>
-          </a:solidFill>
-          <a:ln w="12700">
-            <a:solidFill>
-              <a:srgbClr val="1E2E4A"/>
-            </a:solidFill>
-            <a:prstDash val="solid"/>
-          </a:ln>
-        </p:spPr>
-      </p:sp>
-      <p:sp>
-        <p:nvSpPr>
-          <p:cNvPr id="11" name="Text 9"/>
-          <p:cNvSpPr txBox="1"/>
-          <p:nvPr/>
-        </p:nvSpPr>
-        <p:spPr>
-          <a:xfrm>
-            <a:off x="1042416" y="3749040"/>
-            <a:ext cx="6035040" cy="310896"/>
-          </a:xfrm>
-          <a:prstGeom prst="rect">
-            <a:avLst/>
-          </a:prstGeom>
-          <a:noFill/>
-          <a:ln/>
-        </p:spPr>
-        <p:txBody>
-          <a:bodyPr wrap="square" lIns="0" tIns="0" rIns="0" bIns="0" rtlCol="0" anchor="ctr"/>
-          <a:lstStyle/>
-          <a:p>
-            <a:pPr indent="0" marL="0">
-              <a:buNone/>
-            </a:pPr>
-            <a:r>
-              <a:rPr lang="en-US" sz="1300" b="1" dirty="0">
-                <a:solidFill>
-                  <a:srgbClr val="FFFFFF"/>
-                </a:solidFill>
-              </a:rPr>
-              <a:t>imf_weo_april_2026.csv</a:t>
-            </a:r>
-            <a:endParaRPr lang="en-US" sz="1300" dirty="0"/>
-          </a:p>
-        </p:txBody>
-      </p:sp>
-      <p:sp>
-        <p:nvSpPr>
-          <p:cNvPr id="12" name="Text 10"/>
-          <p:cNvSpPr txBox="1"/>
-          <p:nvPr/>
-        </p:nvSpPr>
-        <p:spPr>
-          <a:xfrm>
-            <a:off x="1042416" y="4059936"/>
-            <a:ext cx="6035040" cy="274320"/>
-          </a:xfrm>
-          <a:prstGeom prst="rect">
-            <a:avLst/>
-          </a:prstGeom>
-          <a:noFill/>
-          <a:ln/>
-        </p:spPr>
-        <p:txBody>
-          <a:bodyPr wrap="square" lIns="0" tIns="0" rIns="0" bIns="0" rtlCol="0" anchor="ctr"/>
-          <a:lstStyle/>
-          <a:p>
-            <a:pPr indent="0" marL="0">
-              <a:buNone/>
-            </a:pPr>
-            <a:r>
-              <a:rPr lang="en-US" sz="1050" dirty="0">
-                <a:solidFill>
-                  <a:srgbClr val="8FA6C4"/>
-                </a:solidFill>
-              </a:rPr>
-              <a:t>Source data, 2,901 rows × 25 columns</a:t>
-            </a:r>
-            <a:endParaRPr lang="en-US" sz="1050" dirty="0"/>
-          </a:p>
-        </p:txBody>
-      </p:sp>
-      <p:sp>
-        <p:nvSpPr>
-          <p:cNvPr id="13" name="repo-card"/>
-          <p:cNvSpPr/>
-          <p:nvPr/>
-        </p:nvSpPr>
-        <p:spPr>
-          <a:xfrm>
-            <a:off x="7635240" y="2011680"/>
-            <a:ext cx="3703320" cy="2340864"/>
-          </a:xfrm>
-          <a:prstGeom prst="roundRect">
-            <a:avLst>
-              <a:gd name="adj" fmla="val 2734"/>
-            </a:avLst>
-          </a:prstGeom>
-          <a:solidFill>
-            <a:srgbClr val="1E2E4A"/>
-          </a:solidFill>
-          <a:ln w="15875">
-            <a:solidFill>
-              <a:srgbClr val="D4A017"/>
-            </a:solidFill>
-            <a:prstDash val="solid"/>
-          </a:ln>
-        </p:spPr>
-      </p:sp>
-      <p:sp>
-        <p:nvSpPr>
-          <p:cNvPr id="14" name="Text 12"/>
-          <p:cNvSpPr txBox="1"/>
-          <p:nvPr/>
-        </p:nvSpPr>
-        <p:spPr>
-          <a:xfrm>
-            <a:off x="7863840" y="2194560"/>
-            <a:ext cx="3246120" cy="274320"/>
-          </a:xfrm>
-          <a:prstGeom prst="rect">
-            <a:avLst/>
-          </a:prstGeom>
-          <a:noFill/>
-          <a:ln/>
-        </p:spPr>
-        <p:txBody>
-          <a:bodyPr wrap="square" lIns="0" tIns="0" rIns="0" bIns="0" rtlCol="0" anchor="ctr"/>
-          <a:lstStyle/>
-          <a:p>
-            <a:pPr indent="0" marL="0">
-              <a:buNone/>
-            </a:pPr>
-            <a:r>
-              <a:rPr lang="en-US" sz="1050" b="1" spc="150" kern="0" dirty="0">
-                <a:solidFill>
-                  <a:srgbClr val="D4A017"/>
-                </a:solidFill>
-              </a:rPr>
-              <a:t>ACTIVE PROFILE LINK</a:t>
-            </a:r>
-            <a:endParaRPr lang="en-US" sz="1050" dirty="0"/>
-          </a:p>
-        </p:txBody>
-      </p:sp>
-      <p:sp>
-        <p:nvSpPr>
-          <p:cNvPr id="15" name="Text 13"/>
-          <p:cNvSpPr txBox="1"/>
-          <p:nvPr/>
-        </p:nvSpPr>
-        <p:spPr>
-          <a:xfrm>
-            <a:off x="7863840" y="2523744"/>
-            <a:ext cx="3246120" cy="1737360"/>
-          </a:xfrm>
-          <a:prstGeom prst="rect">
-            <a:avLst/>
-          </a:prstGeom>
-          <a:noFill/>
-          <a:ln/>
-        </p:spPr>
-        <p:txBody>
-          <a:bodyPr wrap="square" lIns="0" tIns="0" rIns="0" bIns="0" rtlCol="0" anchor="ctr"/>
-          <a:lstStyle/>
-          <a:p>
-            <a:pPr indent="0" marL="0">
-              <a:lnSpc>
-                <a:spcPct val="108000"/>
-              </a:lnSpc>
-              <a:buNone/>
-            </a:pPr>
-            <a:r>
-              <a:rPr lang="en-US" sz="1200" b="1" dirty="0">
-                <a:solidFill>
-                  <a:srgbClr val="FFFFFF"/>
-                </a:solidFill>
-              </a:rPr>
-              <a:t>Repository</a:t>
-            </a:r>
-            <a:endParaRPr lang="en-US" sz="1100" dirty="0"/>
-          </a:p>
-          <a:p>
-            <a:pPr indent="0" marL="0">
-              <a:lnSpc>
-                <a:spcPct val="108000"/>
-              </a:lnSpc>
-              <a:buNone/>
-            </a:pPr>
-            <a:r>
-              <a:rPr lang="en-US" sz="1100" dirty="0">
-                <a:solidFill>
-                  <a:srgbClr val="CADCFC"/>
-                </a:solidFill>
-              </a:rPr>
-              <a:t>github.com/swayd03/</a:t>
-            </a:r>
-            <a:endParaRPr lang="en-US" sz="1100" dirty="0"/>
-          </a:p>
-          <a:p>
-            <a:pPr indent="0" marL="0">
-              <a:lnSpc>
-                <a:spcPct val="108000"/>
-              </a:lnSpc>
-              <a:buNone/>
-            </a:pPr>
-            <a:r>
-              <a:rPr lang="en-US" sz="1100" dirty="0">
-                <a:solidFill>
-                  <a:srgbClr val="CADCFC"/>
-                </a:solidFill>
-              </a:rPr>
-              <a:t>imf-weo-capstone</a:t>
-            </a:r>
-            <a:endParaRPr lang="en-US" sz="1100" dirty="0"/>
-          </a:p>
-          <a:p>
-            <a:pPr indent="0" marL="0">
-              <a:lnSpc>
-                <a:spcPct val="108000"/>
-              </a:lnSpc>
-              <a:buNone/>
-            </a:pPr>
-            <a:endParaRPr lang="en-US" sz="1100" dirty="0"/>
-          </a:p>
-          <a:p>
-            <a:pPr indent="0" marL="0">
-              <a:lnSpc>
-                <a:spcPct val="108000"/>
-              </a:lnSpc>
-              <a:buNone/>
-            </a:pPr>
-            <a:r>
-              <a:rPr lang="en-US" sz="1200" b="1" dirty="0">
-                <a:solidFill>
-                  <a:srgbClr val="FFFFFF"/>
-                </a:solidFill>
-              </a:rPr>
-              <a:t>GitHub profile</a:t>
-            </a:r>
-            <a:endParaRPr lang="en-US" sz="1100" dirty="0"/>
-          </a:p>
-          <a:p>
-            <a:pPr indent="0" marL="0">
-              <a:lnSpc>
-                <a:spcPct val="108000"/>
-              </a:lnSpc>
-              <a:buNone/>
-            </a:pPr>
-            <a:r>
-              <a:rPr lang="en-US" sz="1100" dirty="0">
-                <a:solidFill>
-                  <a:srgbClr val="CADCFC"/>
-                </a:solidFill>
-              </a:rPr>
-              <a:t>github.com/swayd03</a:t>
-            </a:r>
-            <a:endParaRPr lang="en-US" sz="1100" dirty="0"/>
-          </a:p>
-        </p:txBody>
-      </p:sp>
-      <p:sp>
-        <p:nvSpPr>
-          <p:cNvPr id="16" name="submission-card"/>
-          <p:cNvSpPr/>
-          <p:nvPr/>
-        </p:nvSpPr>
-        <p:spPr>
-          <a:xfrm>
-            <a:off x="822960" y="4809744"/>
-            <a:ext cx="10515600" cy="658368"/>
-          </a:xfrm>
-          <a:prstGeom prst="roundRect">
-            <a:avLst>
-              <a:gd name="adj" fmla="val 8333"/>
-            </a:avLst>
-          </a:prstGeom>
-          <a:solidFill>
-            <a:srgbClr val="1E2E4A"/>
-          </a:solidFill>
-          <a:ln w="12700">
-            <a:solidFill>
-              <a:srgbClr val="1E2E4A"/>
-            </a:solidFill>
-            <a:prstDash val="solid"/>
-          </a:ln>
-        </p:spPr>
-      </p:sp>
-      <p:sp>
-        <p:nvSpPr>
-          <p:cNvPr id="17" name="Text 15"/>
-          <p:cNvSpPr txBox="1"/>
-          <p:nvPr/>
-        </p:nvSpPr>
-        <p:spPr>
-          <a:xfrm>
-            <a:off x="1042416" y="4809744"/>
-            <a:ext cx="10058400" cy="658368"/>
-          </a:xfrm>
-          <a:prstGeom prst="rect">
-            <a:avLst/>
-          </a:prstGeom>
-          <a:noFill/>
-          <a:ln/>
-        </p:spPr>
-        <p:txBody>
-          <a:bodyPr wrap="square" lIns="0" tIns="0" rIns="0" bIns="0" rtlCol="0" anchor="ctr"/>
-          <a:lstStyle/>
-          <a:p>
-            <a:pPr indent="0" marL="0">
-              <a:buNone/>
-            </a:pPr>
-            <a:r>
               <a:rPr lang="en-US" sz="1200" dirty="0">
                 <a:solidFill>
                   <a:srgbClr val="8FA6C4"/>
@@ -8722,7 +8493,7 @@
       </p:sp>
       <p:sp>
         <p:nvSpPr>
-          <p:cNvPr id="18" name="Text 16"/>
+          <p:cNvPr id="11" name="Text 9"/>
           <p:cNvSpPr txBox="1"/>
           <p:nvPr/>
         </p:nvSpPr>

</xml_diff>